<commit_message>
feat: interactive landing with forgery challenge and inspector simulator
The hero lets visitors edit a real signed certificate and watch the
phone-side check reject it. A simulator shows the legal limit and
verdict computed from OIML R 76. Role cards sign in to any evaluator
account in one click. Removes repeated sections.

Co-Authored-By: Claude Opus 5.5 <noreply@anthropic.com>
</commit_message>
<xml_diff>
--- a/sih-submission/08-final-2026-09-30/TULA_SIH2026_FriendlyFire_v4.pptx
+++ b/sih-submission/08-final-2026-09-30/TULA_SIH2026_FriendlyFire_v4.pptx
@@ -14596,7 +14596,7 @@
         </p:nvSpPr>
         <p:spPr>
           <a:xfrm>
-            <a:off x="365760" y="4663440"/>
+            <a:off x="365760" y="4645152"/>
             <a:ext cx="6949440" cy="274320"/>
           </a:xfrm>
           <a:prstGeom prst="rect">
@@ -14618,7 +14618,7 @@
                 </a:solidFill>
                 <a:latin typeface="Calibri"/>
               </a:rPr>
-              <a:t>TESTING WITH REAL LEGAL METROLOGY OFFICERS (before final build)</a:t>
+              <a:t>HOW WE TEST WITH REAL OFFICERS, THEN SCALE</a:t>
             </a:r>
           </a:p>
         </p:txBody>
@@ -14631,12 +14631,12 @@
         </p:nvSpPr>
         <p:spPr>
           <a:xfrm>
-            <a:off x="365760" y="4937760"/>
-            <a:ext cx="1655063" cy="822960"/>
+            <a:off x="365760" y="4910328"/>
+            <a:ext cx="1655063" cy="914400"/>
           </a:xfrm>
           <a:prstGeom prst="roundRect">
             <a:avLst>
-              <a:gd name="adj" fmla="val 6666"/>
+              <a:gd name="adj" fmla="val 6000"/>
             </a:avLst>
           </a:prstGeom>
           <a:solidFill>
@@ -14662,48 +14662,84 @@
           </a:fontRef>
         </p:style>
         <p:txBody>
-          <a:bodyPr rtlCol="0" anchor="t" wrap="square" lIns="82296" rIns="82296" tIns="27432" bIns="27432"/>
+          <a:bodyPr rtlCol="0" anchor="t" wrap="square" lIns="73152" rIns="73152" tIns="27432" bIns="27432"/>
           <a:lstStyle/>
           <a:p>
             <a:pPr algn="l"/>
             <a:r>
-              <a:rPr sz="1050" b="1" i="0">
+              <a:rPr sz="1000" b="1" i="0">
                 <a:solidFill>
                   <a:srgbClr val="D9661F"/>
                 </a:solidFill>
                 <a:latin typeface="Calibri"/>
               </a:rPr>
-              <a:t>Who</a:t>
+              <a:t>1 · Field trial</a:t>
             </a:r>
           </a:p>
           <a:p>
             <a:pPr algn="l"/>
             <a:r>
-              <a:rPr sz="900" b="0" i="0">
+              <a:rPr sz="850" b="0" i="0">
                 <a:solidFill>
                   <a:srgbClr val="1F2937"/>
                 </a:solidFill>
                 <a:latin typeface="Calibri"/>
               </a:rPr>
-              <a:t>5 LMOs + 1 GATC, one district</a:t>
-            </a:r>
-          </a:p>
-        </p:txBody>
-      </p:sp>
-      <p:sp>
-        <p:nvSpPr>
-          <p:cNvPr id="17446" name="Rounded Rectangle 17445"/>
+              <a:t>5 LMOs + 1 GATC, 10 real inspections each. Go ahead only if usability (SUS) ≥ 70</a:t>
+            </a:r>
+          </a:p>
+        </p:txBody>
+      </p:sp>
+      <p:cxnSp>
+        <p:nvCxnSpPr>
+          <p:cNvPr id="17446" name="Connector 17445"/>
+          <p:cNvCxnSpPr/>
+          <p:nvPr/>
+        </p:nvCxnSpPr>
+        <p:spPr>
+          <a:xfrm>
+            <a:off x="2025395" y="5367528"/>
+            <a:ext cx="100584" cy="0"/>
+          </a:xfrm>
+          <a:prstGeom prst="line">
+            <a:avLst/>
+          </a:prstGeom>
+          <a:ln w="19050">
+            <a:solidFill>
+              <a:srgbClr val="D9661F"/>
+            </a:solidFill>
+            <a:tailEnd type="triangle" w="med" h="med"/>
+          </a:ln>
+        </p:spPr>
+        <p:style>
+          <a:lnRef idx="2">
+            <a:schemeClr val="accent1"/>
+          </a:lnRef>
+          <a:fillRef idx="0">
+            <a:schemeClr val="accent1"/>
+          </a:fillRef>
+          <a:effectRef idx="1">
+            <a:schemeClr val="accent1"/>
+          </a:effectRef>
+          <a:fontRef idx="minor">
+            <a:schemeClr val="tx1"/>
+          </a:fontRef>
+        </p:style>
+      </p:cxnSp>
+      <p:sp>
+        <p:nvSpPr>
+          <p:cNvPr id="17447" name="Rounded Rectangle 17446"/>
           <p:cNvSpPr/>
           <p:nvPr/>
         </p:nvSpPr>
         <p:spPr>
           <a:xfrm>
-            <a:off x="2130551" y="4937760"/>
-            <a:ext cx="1655063" cy="822960"/>
+            <a:off x="2130551" y="4910328"/>
+            <a:ext cx="1655063" cy="914400"/>
           </a:xfrm>
           <a:prstGeom prst="roundRect">
             <a:avLst>
-              <a:gd name="adj" fmla="val 6666"/>
+              <a:gd name="adj" fmla="val 6000"/>
             </a:avLst>
           </a:prstGeom>
           <a:solidFill>
@@ -14729,48 +14765,84 @@
           </a:fontRef>
         </p:style>
         <p:txBody>
-          <a:bodyPr rtlCol="0" anchor="t" wrap="square" lIns="82296" rIns="82296" tIns="27432" bIns="27432"/>
+          <a:bodyPr rtlCol="0" anchor="t" wrap="square" lIns="73152" rIns="73152" tIns="27432" bIns="27432"/>
           <a:lstStyle/>
           <a:p>
             <a:pPr algn="l"/>
             <a:r>
-              <a:rPr sz="1050" b="1" i="0">
+              <a:rPr sz="1000" b="1" i="0">
                 <a:solidFill>
                   <a:srgbClr val="D9661F"/>
                 </a:solidFill>
                 <a:latin typeface="Calibri"/>
               </a:rPr>
-              <a:t>What</a:t>
+              <a:t>2 · District pilot</a:t>
             </a:r>
           </a:p>
           <a:p>
             <a:pPr algn="l"/>
             <a:r>
-              <a:rPr sz="900" b="0" i="0">
+              <a:rPr sz="850" b="0" i="0">
                 <a:solidFill>
                   <a:srgbClr val="1F2937"/>
                 </a:solidFill>
                 <a:latin typeface="Calibri"/>
               </a:rPr>
-              <a:t>10 real inspections each, on their phones</a:t>
-            </a:r>
-          </a:p>
-        </p:txBody>
-      </p:sp>
-      <p:sp>
-        <p:nvSpPr>
-          <p:cNvPr id="17447" name="Rounded Rectangle 17446"/>
+              <a:t>All instruments of one district, measured against the paper register</a:t>
+            </a:r>
+          </a:p>
+        </p:txBody>
+      </p:sp>
+      <p:cxnSp>
+        <p:nvCxnSpPr>
+          <p:cNvPr id="17448" name="Connector 17447"/>
+          <p:cNvCxnSpPr/>
+          <p:nvPr/>
+        </p:nvCxnSpPr>
+        <p:spPr>
+          <a:xfrm>
+            <a:off x="3790187" y="5367528"/>
+            <a:ext cx="100585" cy="0"/>
+          </a:xfrm>
+          <a:prstGeom prst="line">
+            <a:avLst/>
+          </a:prstGeom>
+          <a:ln w="19050">
+            <a:solidFill>
+              <a:srgbClr val="D9661F"/>
+            </a:solidFill>
+            <a:tailEnd type="triangle" w="med" h="med"/>
+          </a:ln>
+        </p:spPr>
+        <p:style>
+          <a:lnRef idx="2">
+            <a:schemeClr val="accent1"/>
+          </a:lnRef>
+          <a:fillRef idx="0">
+            <a:schemeClr val="accent1"/>
+          </a:fillRef>
+          <a:effectRef idx="1">
+            <a:schemeClr val="accent1"/>
+          </a:effectRef>
+          <a:fontRef idx="minor">
+            <a:schemeClr val="tx1"/>
+          </a:fontRef>
+        </p:style>
+      </p:cxnSp>
+      <p:sp>
+        <p:nvSpPr>
+          <p:cNvPr id="17449" name="Rounded Rectangle 17448"/>
           <p:cNvSpPr/>
           <p:nvPr/>
         </p:nvSpPr>
         <p:spPr>
           <a:xfrm>
-            <a:off x="3895344" y="4937760"/>
-            <a:ext cx="1655063" cy="822960"/>
+            <a:off x="3895344" y="4910328"/>
+            <a:ext cx="1655063" cy="914400"/>
           </a:xfrm>
           <a:prstGeom prst="roundRect">
             <a:avLst>
-              <a:gd name="adj" fmla="val 6666"/>
+              <a:gd name="adj" fmla="val 6000"/>
             </a:avLst>
           </a:prstGeom>
           <a:solidFill>
@@ -14796,48 +14868,84 @@
           </a:fontRef>
         </p:style>
         <p:txBody>
-          <a:bodyPr rtlCol="0" anchor="t" wrap="square" lIns="82296" rIns="82296" tIns="27432" bIns="27432"/>
+          <a:bodyPr rtlCol="0" anchor="t" wrap="square" lIns="73152" rIns="73152" tIns="27432" bIns="27432"/>
           <a:lstStyle/>
           <a:p>
             <a:pPr algn="l"/>
             <a:r>
-              <a:rPr sz="1050" b="1" i="0">
+              <a:rPr sz="1000" b="1" i="0">
                 <a:solidFill>
                   <a:srgbClr val="D9661F"/>
                 </a:solidFill>
                 <a:latin typeface="Calibri"/>
               </a:rPr>
-              <a:t>Measure</a:t>
+              <a:t>3 · State rollout</a:t>
             </a:r>
           </a:p>
           <a:p>
             <a:pPr algn="l"/>
             <a:r>
-              <a:rPr sz="900" b="0" i="0">
+              <a:rPr sz="850" b="0" i="0">
                 <a:solidFill>
                   <a:srgbClr val="1F2937"/>
                 </a:solidFill>
                 <a:latin typeface="Calibri"/>
               </a:rPr>
-              <a:t>minutes per inspection, errors, usability score (SUS)</a:t>
-            </a:r>
-          </a:p>
-        </p:txBody>
-      </p:sp>
-      <p:sp>
-        <p:nvSpPr>
-          <p:cNvPr id="17448" name="Rounded Rectangle 17447"/>
+              <a:t>State loads fees and officers; NIC SMS, treasury, e-Pramaan</a:t>
+            </a:r>
+          </a:p>
+        </p:txBody>
+      </p:sp>
+      <p:cxnSp>
+        <p:nvCxnSpPr>
+          <p:cNvPr id="17450" name="Connector 17449"/>
+          <p:cNvCxnSpPr/>
+          <p:nvPr/>
+        </p:nvCxnSpPr>
+        <p:spPr>
+          <a:xfrm>
+            <a:off x="5554979" y="5367528"/>
+            <a:ext cx="100585" cy="0"/>
+          </a:xfrm>
+          <a:prstGeom prst="line">
+            <a:avLst/>
+          </a:prstGeom>
+          <a:ln w="19050">
+            <a:solidFill>
+              <a:srgbClr val="D9661F"/>
+            </a:solidFill>
+            <a:tailEnd type="triangle" w="med" h="med"/>
+          </a:ln>
+        </p:spPr>
+        <p:style>
+          <a:lnRef idx="2">
+            <a:schemeClr val="accent1"/>
+          </a:lnRef>
+          <a:fillRef idx="0">
+            <a:schemeClr val="accent1"/>
+          </a:fillRef>
+          <a:effectRef idx="1">
+            <a:schemeClr val="accent1"/>
+          </a:effectRef>
+          <a:fontRef idx="minor">
+            <a:schemeClr val="tx1"/>
+          </a:fontRef>
+        </p:style>
+      </p:cxnSp>
+      <p:sp>
+        <p:nvSpPr>
+          <p:cNvPr id="17451" name="Rounded Rectangle 17450"/>
           <p:cNvSpPr/>
           <p:nvPr/>
         </p:nvSpPr>
         <p:spPr>
           <a:xfrm>
-            <a:off x="5660136" y="4937760"/>
-            <a:ext cx="1655063" cy="822960"/>
+            <a:off x="5660136" y="4910328"/>
+            <a:ext cx="1655063" cy="914400"/>
           </a:xfrm>
           <a:prstGeom prst="roundRect">
             <a:avLst>
-              <a:gd name="adj" fmla="val 6666"/>
+              <a:gd name="adj" fmla="val 6000"/>
             </a:avLst>
           </a:prstGeom>
           <a:solidFill>
@@ -14863,43 +14971,43 @@
           </a:fontRef>
         </p:style>
         <p:txBody>
-          <a:bodyPr rtlCol="0" anchor="t" wrap="square" lIns="82296" rIns="82296" tIns="27432" bIns="27432"/>
+          <a:bodyPr rtlCol="0" anchor="t" wrap="square" lIns="73152" rIns="73152" tIns="27432" bIns="27432"/>
           <a:lstStyle/>
           <a:p>
             <a:pPr algn="l"/>
             <a:r>
-              <a:rPr sz="1050" b="1" i="0">
+              <a:rPr sz="1000" b="1" i="0">
                 <a:solidFill>
                   <a:srgbClr val="D9661F"/>
                 </a:solidFill>
                 <a:latin typeface="Calibri"/>
               </a:rPr>
-              <a:t>Pass mark</a:t>
+              <a:t>4 · Multi-State</a:t>
             </a:r>
           </a:p>
           <a:p>
             <a:pPr algn="l"/>
             <a:r>
-              <a:rPr sz="900" b="0" i="0">
+              <a:rPr sz="850" b="0" i="0">
                 <a:solidFill>
                   <a:srgbClr val="1F2937"/>
                 </a:solidFill>
                 <a:latin typeface="Calibri"/>
               </a:rPr>
-              <a:t>SUS ≥ 70, no data-entry blockers</a:t>
-            </a:r>
-          </a:p>
-        </p:txBody>
-      </p:sp>
-      <p:sp>
-        <p:nvSpPr>
-          <p:cNvPr id="17449" name="TextBox 17448"/>
+              <a:t>DoCA offers it to States as a shared platform or on State cloud</a:t>
+            </a:r>
+          </a:p>
+        </p:txBody>
+      </p:sp>
+      <p:sp>
+        <p:nvSpPr>
+          <p:cNvPr id="17452" name="TextBox 17451"/>
           <p:cNvSpPr txBox="1"/>
           <p:nvPr/>
         </p:nvSpPr>
         <p:spPr>
           <a:xfrm>
-            <a:off x="365760" y="5833872"/>
+            <a:off x="365760" y="5879592"/>
             <a:ext cx="6949440" cy="365760"/>
           </a:xfrm>
           <a:prstGeom prst="rect">
@@ -14915,29 +15023,29 @@
           <a:p>
             <a:pPr algn="l"/>
             <a:r>
-              <a:rPr sz="950" b="1" i="0">
+              <a:rPr sz="900" b="1" i="0">
                 <a:solidFill>
                   <a:srgbClr val="1E7B4A"/>
                 </a:solidFill>
                 <a:latin typeface="Calibri"/>
               </a:rPr>
-              <a:t>Feasible now: </a:t>
-            </a:r>
-            <a:r>
-              <a:rPr sz="950" b="0" i="0">
+              <a:t>Market and cost: </a:t>
+            </a:r>
+            <a:r>
+              <a:rPr sz="900" b="0" i="0">
                 <a:solidFill>
                   <a:srgbClr val="1F2937"/>
                 </a:solidFill>
                 <a:latin typeface="Calibri"/>
               </a:rPr>
-              <a:t>open-source stack, free tiers cover a district pilot, mirrors today's LMO / GATC process, follows the LM Act 2009 and GATC Rules 2013.</a:t>
-            </a:r>
-          </a:p>
-        </p:txBody>
-      </p:sp>
-      <p:sp>
-        <p:nvSpPr>
-          <p:cNvPr id="17450" name="TextBox 17449"/>
+              <a:t>buyers are DoCA and the 36 State / UT Legal Metrology departments; traders and citizens use it free. Open-source; a district runs on free cloud tiers, a State on a hosting and support contract or its own cloud.</a:t>
+            </a:r>
+          </a:p>
+        </p:txBody>
+      </p:sp>
+      <p:sp>
+        <p:nvSpPr>
+          <p:cNvPr id="17453" name="TextBox 17452"/>
           <p:cNvSpPr txBox="1"/>
           <p:nvPr/>
         </p:nvSpPr>
@@ -14972,7 +15080,7 @@
       </p:sp>
       <p:sp>
         <p:nvSpPr>
-          <p:cNvPr id="17451" name="Rectangle 17450"/>
+          <p:cNvPr id="17454" name="Rectangle 17453"/>
           <p:cNvSpPr/>
           <p:nvPr/>
         </p:nvSpPr>
@@ -15025,7 +15133,7 @@
       </p:sp>
       <p:sp>
         <p:nvSpPr>
-          <p:cNvPr id="17452" name="Rectangle 17451"/>
+          <p:cNvPr id="17455" name="Rectangle 17454"/>
           <p:cNvSpPr/>
           <p:nvPr/>
         </p:nvSpPr>
@@ -15078,7 +15186,7 @@
       </p:sp>
       <p:sp>
         <p:nvSpPr>
-          <p:cNvPr id="17453" name="Rectangle 17452"/>
+          <p:cNvPr id="17456" name="Rectangle 17455"/>
           <p:cNvSpPr/>
           <p:nvPr/>
         </p:nvSpPr>
@@ -15131,7 +15239,7 @@
       </p:sp>
       <p:sp>
         <p:nvSpPr>
-          <p:cNvPr id="17454" name="Rectangle 17453"/>
+          <p:cNvPr id="17457" name="Rectangle 17456"/>
           <p:cNvSpPr/>
           <p:nvPr/>
         </p:nvSpPr>
@@ -15184,7 +15292,7 @@
       </p:sp>
       <p:sp>
         <p:nvSpPr>
-          <p:cNvPr id="17455" name="Rectangle 17454"/>
+          <p:cNvPr id="17458" name="Rectangle 17457"/>
           <p:cNvSpPr/>
           <p:nvPr/>
         </p:nvSpPr>
@@ -15237,7 +15345,7 @@
       </p:sp>
       <p:sp>
         <p:nvSpPr>
-          <p:cNvPr id="17456" name="Rectangle 17455"/>
+          <p:cNvPr id="17459" name="Rectangle 17458"/>
           <p:cNvSpPr/>
           <p:nvPr/>
         </p:nvSpPr>
@@ -15290,7 +15398,7 @@
       </p:sp>
       <p:sp>
         <p:nvSpPr>
-          <p:cNvPr id="17457" name="Rectangle 17456"/>
+          <p:cNvPr id="17460" name="Rectangle 17459"/>
           <p:cNvSpPr/>
           <p:nvPr/>
         </p:nvSpPr>
@@ -15343,7 +15451,7 @@
       </p:sp>
       <p:sp>
         <p:nvSpPr>
-          <p:cNvPr id="17458" name="Rectangle 17457"/>
+          <p:cNvPr id="17461" name="Rectangle 17460"/>
           <p:cNvSpPr/>
           <p:nvPr/>
         </p:nvSpPr>
@@ -15396,7 +15504,7 @@
       </p:sp>
       <p:sp>
         <p:nvSpPr>
-          <p:cNvPr id="17459" name="Rectangle 17458"/>
+          <p:cNvPr id="17462" name="Rectangle 17461"/>
           <p:cNvSpPr/>
           <p:nvPr/>
         </p:nvSpPr>
@@ -15449,7 +15557,7 @@
       </p:sp>
       <p:sp>
         <p:nvSpPr>
-          <p:cNvPr id="17460" name="Rectangle 17459"/>
+          <p:cNvPr id="17463" name="Rectangle 17462"/>
           <p:cNvSpPr/>
           <p:nvPr/>
         </p:nvSpPr>
@@ -15502,7 +15610,7 @@
       </p:sp>
       <p:sp>
         <p:nvSpPr>
-          <p:cNvPr id="17461" name="Rectangle 17460"/>
+          <p:cNvPr id="17464" name="Rectangle 17463"/>
           <p:cNvSpPr/>
           <p:nvPr/>
         </p:nvSpPr>
@@ -15555,7 +15663,7 @@
       </p:sp>
       <p:sp>
         <p:nvSpPr>
-          <p:cNvPr id="17462" name="Rectangle 17461"/>
+          <p:cNvPr id="17465" name="Rectangle 17464"/>
           <p:cNvSpPr/>
           <p:nvPr/>
         </p:nvSpPr>
@@ -15608,7 +15716,7 @@
       </p:sp>
       <p:sp>
         <p:nvSpPr>
-          <p:cNvPr id="17463" name="Rounded Rectangle 17462"/>
+          <p:cNvPr id="17466" name="Rounded Rectangle 17465"/>
           <p:cNvSpPr/>
           <p:nvPr/>
         </p:nvSpPr>
@@ -15654,7 +15762,7 @@
       </p:sp>
       <p:pic>
         <p:nvPicPr>
-          <p:cNvPr id="17464" name="Picture 17463" descr="image.png"/>
+          <p:cNvPr id="17467" name="Picture 17466" descr="image.png"/>
           <p:cNvPicPr>
             <a:picLocks noChangeAspect="1"/>
           </p:cNvPicPr>
@@ -15678,7 +15786,7 @@
       </p:pic>
       <p:sp>
         <p:nvSpPr>
-          <p:cNvPr id="17465" name="TextBox 17464"/>
+          <p:cNvPr id="17468" name="TextBox 17467"/>
           <p:cNvSpPr txBox="1"/>
           <p:nvPr/>
         </p:nvSpPr>
@@ -19654,11 +19762,11 @@
         <p:spPr>
           <a:xfrm>
             <a:off x="7589520" y="1444752"/>
-            <a:ext cx="4233672" cy="3337560"/>
+            <a:ext cx="4233672" cy="1874519"/>
           </a:xfrm>
           <a:prstGeom prst="roundRect">
             <a:avLst>
-              <a:gd name="adj" fmla="val 1643"/>
+              <a:gd name="adj" fmla="val 2926"/>
             </a:avLst>
           </a:prstGeom>
           <a:solidFill>
@@ -19734,8 +19842,8 @@
         </p:nvSpPr>
         <p:spPr>
           <a:xfrm>
-            <a:off x="7726680" y="1847088"/>
-            <a:ext cx="3959352" cy="2880360"/>
+            <a:off x="7726680" y="1810512"/>
+            <a:ext cx="3959352" cy="1463040"/>
           </a:xfrm>
           <a:prstGeom prst="rect">
             <a:avLst/>
@@ -19769,7 +19877,7 @@
                 </a:solidFill>
                 <a:latin typeface="Calibri"/>
               </a:rPr>
-              <a:t>The Legal Metrology Act, 2009</a:t>
+              <a:t>LM Act 2009; LM (General) Rules 2011</a:t>
             </a:r>
             <a:r>
               <a:rPr sz="1000" b="0" i="0">
@@ -19803,7 +19911,7 @@
                 </a:solidFill>
                 <a:latin typeface="Calibri"/>
               </a:rPr>
-              <a:t>Legal Metrology (General) Rules, 2011</a:t>
+              <a:t>LM (GATC) Rules 2013; State Enforcement Rules</a:t>
             </a:r>
             <a:r>
               <a:rPr sz="1000" b="0" i="0">
@@ -19837,7 +19945,7 @@
                 </a:solidFill>
                 <a:latin typeface="Calibri"/>
               </a:rPr>
-              <a:t>LM (Government Approved Test Centre) Rules, 2013</a:t>
+              <a:t>OIML R 76-1 (scales), R 117-1 (dispensers)</a:t>
             </a:r>
             <a:r>
               <a:rPr sz="1000" b="0" i="0">
@@ -19846,7 +19954,7 @@
                 </a:solidFill>
                 <a:latin typeface="Calibri"/>
               </a:rPr>
-              <a:t/>
+              <a:t> · oiml.org</a:t>
             </a:r>
           </a:p>
           <a:p>
@@ -19871,7 +19979,7 @@
                 </a:solidFill>
                 <a:latin typeface="Calibri"/>
               </a:rPr>
-              <a:t>State LM (Enforcement) Rules</a:t>
+              <a:t>IT Act 2000, DPDP Act 2023</a:t>
             </a:r>
             <a:r>
               <a:rPr sz="1000" b="0" i="0">
@@ -19905,7 +20013,7 @@
                 </a:solidFill>
                 <a:latin typeface="Calibri"/>
               </a:rPr>
-              <a:t>OIML R 76-1 and R 117-1</a:t>
+              <a:t>Supabase, Vercel and Gemini API docs</a:t>
             </a:r>
             <a:r>
               <a:rPr sz="1000" b="0" i="0">
@@ -19914,128 +20022,430 @@
                 </a:solidFill>
                 <a:latin typeface="Calibri"/>
               </a:rPr>
-              <a:t> · oiml.org</a:t>
-            </a:r>
-          </a:p>
-          <a:p>
-            <a:pPr>
-              <a:spcAft>
-                <a:spcPts val="300"/>
-              </a:spcAft>
-            </a:pPr>
-            <a:r>
-              <a:rPr sz="1000" b="1" i="0">
-                <a:solidFill>
-                  <a:srgbClr val="0070C0"/>
-                </a:solidFill>
-                <a:latin typeface="Calibri"/>
-              </a:rPr>
-              <a:t>6.  </a:t>
-            </a:r>
-            <a:r>
-              <a:rPr sz="1000" b="1" i="0">
+              <a:t/>
+            </a:r>
+          </a:p>
+        </p:txBody>
+      </p:sp>
+      <p:sp>
+        <p:nvSpPr>
+          <p:cNvPr id="17436" name="TextBox 17435"/>
+          <p:cNvSpPr txBox="1"/>
+          <p:nvPr/>
+        </p:nvSpPr>
+        <p:spPr>
+          <a:xfrm>
+            <a:off x="7589520" y="3401568"/>
+            <a:ext cx="4233672" cy="274320"/>
+          </a:xfrm>
+          <a:prstGeom prst="rect">
+            <a:avLst/>
+          </a:prstGeom>
+          <a:noFill/>
+        </p:spPr>
+        <p:txBody>
+          <a:bodyPr wrap="square" anchor="t" lIns="0" rIns="0" tIns="0" bIns="0">
+            <a:spAutoFit/>
+          </a:bodyPr>
+          <a:lstStyle/>
+          <a:p>
+            <a:pPr algn="l"/>
+            <a:r>
+              <a:rPr sz="1150" b="1" i="0">
                 <a:solidFill>
                   <a:srgbClr val="1F3F6E"/>
                 </a:solidFill>
                 <a:latin typeface="Calibri"/>
               </a:rPr>
-              <a:t>IT Act 2000, DPDP Act 2023</a:t>
-            </a:r>
-            <a:r>
-              <a:rPr sz="1000" b="0" i="0">
+              <a:t>COMPARED WITH TODAY</a:t>
+            </a:r>
+          </a:p>
+        </p:txBody>
+      </p:sp>
+      <p:sp>
+        <p:nvSpPr>
+          <p:cNvPr id="17437" name="Rectangle 17436"/>
+          <p:cNvSpPr/>
+          <p:nvPr/>
+        </p:nvSpPr>
+        <p:spPr>
+          <a:xfrm>
+            <a:off x="7589520" y="3639312"/>
+            <a:ext cx="1051560" cy="201168"/>
+          </a:xfrm>
+          <a:prstGeom prst="rect">
+            <a:avLst/>
+          </a:prstGeom>
+          <a:solidFill>
+            <a:srgbClr val="1F3F6E"/>
+          </a:solidFill>
+          <a:ln>
+            <a:noFill/>
+          </a:ln>
+          <a:effectLst/>
+        </p:spPr>
+        <p:style>
+          <a:lnRef idx="1">
+            <a:schemeClr val="accent1"/>
+          </a:lnRef>
+          <a:fillRef idx="3">
+            <a:schemeClr val="accent1"/>
+          </a:fillRef>
+          <a:effectRef idx="2">
+            <a:schemeClr val="accent1"/>
+          </a:effectRef>
+          <a:fontRef idx="minor">
+            <a:schemeClr val="lt1"/>
+          </a:fontRef>
+        </p:style>
+        <p:txBody>
+          <a:bodyPr rtlCol="0" anchor="ctr" wrap="square" lIns="45720" rIns="45720" tIns="27432" bIns="27432"/>
+          <a:lstStyle/>
+          <a:p>
+            <a:pPr algn="l"/>
+            <a:r>
+              <a:rPr sz="800" b="1" i="0">
+                <a:solidFill>
+                  <a:srgbClr val="FFFFFF"/>
+                </a:solidFill>
+                <a:latin typeface="Calibri"/>
+              </a:rPr>
+              <a:t/>
+            </a:r>
+          </a:p>
+        </p:txBody>
+      </p:sp>
+      <p:sp>
+        <p:nvSpPr>
+          <p:cNvPr id="17438" name="Rectangle 17437"/>
+          <p:cNvSpPr/>
+          <p:nvPr/>
+        </p:nvSpPr>
+        <p:spPr>
+          <a:xfrm>
+            <a:off x="8641080" y="3639312"/>
+            <a:ext cx="868680" cy="201168"/>
+          </a:xfrm>
+          <a:prstGeom prst="rect">
+            <a:avLst/>
+          </a:prstGeom>
+          <a:solidFill>
+            <a:srgbClr val="1F3F6E"/>
+          </a:solidFill>
+          <a:ln>
+            <a:noFill/>
+          </a:ln>
+          <a:effectLst/>
+        </p:spPr>
+        <p:style>
+          <a:lnRef idx="1">
+            <a:schemeClr val="accent1"/>
+          </a:lnRef>
+          <a:fillRef idx="3">
+            <a:schemeClr val="accent1"/>
+          </a:fillRef>
+          <a:effectRef idx="2">
+            <a:schemeClr val="accent1"/>
+          </a:effectRef>
+          <a:fontRef idx="minor">
+            <a:schemeClr val="lt1"/>
+          </a:fontRef>
+        </p:style>
+        <p:txBody>
+          <a:bodyPr rtlCol="0" anchor="ctr" wrap="square" lIns="45720" rIns="45720" tIns="27432" bIns="27432"/>
+          <a:lstStyle/>
+          <a:p>
+            <a:pPr algn="l"/>
+            <a:r>
+              <a:rPr sz="800" b="1" i="0">
+                <a:solidFill>
+                  <a:srgbClr val="FFFFFF"/>
+                </a:solidFill>
+                <a:latin typeface="Calibri"/>
+              </a:rPr>
+              <a:t>Paper</a:t>
+            </a:r>
+          </a:p>
+        </p:txBody>
+      </p:sp>
+      <p:sp>
+        <p:nvSpPr>
+          <p:cNvPr id="17439" name="Rectangle 17438"/>
+          <p:cNvSpPr/>
+          <p:nvPr/>
+        </p:nvSpPr>
+        <p:spPr>
+          <a:xfrm>
+            <a:off x="9509760" y="3639312"/>
+            <a:ext cx="1097280" cy="201168"/>
+          </a:xfrm>
+          <a:prstGeom prst="rect">
+            <a:avLst/>
+          </a:prstGeom>
+          <a:solidFill>
+            <a:srgbClr val="1F3F6E"/>
+          </a:solidFill>
+          <a:ln>
+            <a:noFill/>
+          </a:ln>
+          <a:effectLst/>
+        </p:spPr>
+        <p:style>
+          <a:lnRef idx="1">
+            <a:schemeClr val="accent1"/>
+          </a:lnRef>
+          <a:fillRef idx="3">
+            <a:schemeClr val="accent1"/>
+          </a:fillRef>
+          <a:effectRef idx="2">
+            <a:schemeClr val="accent1"/>
+          </a:effectRef>
+          <a:fontRef idx="minor">
+            <a:schemeClr val="lt1"/>
+          </a:fontRef>
+        </p:style>
+        <p:txBody>
+          <a:bodyPr rtlCol="0" anchor="ctr" wrap="square" lIns="45720" rIns="45720" tIns="27432" bIns="27432"/>
+          <a:lstStyle/>
+          <a:p>
+            <a:pPr algn="l"/>
+            <a:r>
+              <a:rPr sz="800" b="1" i="0">
+                <a:solidFill>
+                  <a:srgbClr val="FFFFFF"/>
+                </a:solidFill>
+                <a:latin typeface="Calibri"/>
+              </a:rPr>
+              <a:t>Typical State portal</a:t>
+            </a:r>
+          </a:p>
+        </p:txBody>
+      </p:sp>
+      <p:sp>
+        <p:nvSpPr>
+          <p:cNvPr id="17440" name="Rectangle 17439"/>
+          <p:cNvSpPr/>
+          <p:nvPr/>
+        </p:nvSpPr>
+        <p:spPr>
+          <a:xfrm>
+            <a:off x="10607040" y="3639312"/>
+            <a:ext cx="1216152" cy="201168"/>
+          </a:xfrm>
+          <a:prstGeom prst="rect">
+            <a:avLst/>
+          </a:prstGeom>
+          <a:solidFill>
+            <a:srgbClr val="1F3F6E"/>
+          </a:solidFill>
+          <a:ln>
+            <a:noFill/>
+          </a:ln>
+          <a:effectLst/>
+        </p:spPr>
+        <p:style>
+          <a:lnRef idx="1">
+            <a:schemeClr val="accent1"/>
+          </a:lnRef>
+          <a:fillRef idx="3">
+            <a:schemeClr val="accent1"/>
+          </a:fillRef>
+          <a:effectRef idx="2">
+            <a:schemeClr val="accent1"/>
+          </a:effectRef>
+          <a:fontRef idx="minor">
+            <a:schemeClr val="lt1"/>
+          </a:fontRef>
+        </p:style>
+        <p:txBody>
+          <a:bodyPr rtlCol="0" anchor="ctr" wrap="square" lIns="45720" rIns="45720" tIns="27432" bIns="27432"/>
+          <a:lstStyle/>
+          <a:p>
+            <a:pPr algn="l"/>
+            <a:r>
+              <a:rPr sz="800" b="1" i="0">
+                <a:solidFill>
+                  <a:srgbClr val="FFFFFF"/>
+                </a:solidFill>
+                <a:latin typeface="Calibri"/>
+              </a:rPr>
+              <a:t>TULA</a:t>
+            </a:r>
+          </a:p>
+        </p:txBody>
+      </p:sp>
+      <p:sp>
+        <p:nvSpPr>
+          <p:cNvPr id="17441" name="Rectangle 17440"/>
+          <p:cNvSpPr/>
+          <p:nvPr/>
+        </p:nvSpPr>
+        <p:spPr>
+          <a:xfrm>
+            <a:off x="7589520" y="3840480"/>
+            <a:ext cx="1051560" cy="201168"/>
+          </a:xfrm>
+          <a:prstGeom prst="rect">
+            <a:avLst/>
+          </a:prstGeom>
+          <a:solidFill>
+            <a:srgbClr val="F1F4F8"/>
+          </a:solidFill>
+          <a:ln>
+            <a:noFill/>
+          </a:ln>
+          <a:effectLst/>
+        </p:spPr>
+        <p:style>
+          <a:lnRef idx="1">
+            <a:schemeClr val="accent1"/>
+          </a:lnRef>
+          <a:fillRef idx="3">
+            <a:schemeClr val="accent1"/>
+          </a:fillRef>
+          <a:effectRef idx="2">
+            <a:schemeClr val="accent1"/>
+          </a:effectRef>
+          <a:fontRef idx="minor">
+            <a:schemeClr val="lt1"/>
+          </a:fontRef>
+        </p:style>
+        <p:txBody>
+          <a:bodyPr rtlCol="0" anchor="ctr" wrap="square" lIns="45720" rIns="45720" tIns="27432" bIns="27432"/>
+          <a:lstStyle/>
+          <a:p>
+            <a:pPr algn="l"/>
+            <a:r>
+              <a:rPr sz="800" b="1" i="0">
                 <a:solidFill>
                   <a:srgbClr val="1F2937"/>
                 </a:solidFill>
                 <a:latin typeface="Calibri"/>
               </a:rPr>
-              <a:t/>
-            </a:r>
-          </a:p>
-          <a:p>
-            <a:pPr>
-              <a:spcAft>
-                <a:spcPts val="300"/>
-              </a:spcAft>
-            </a:pPr>
-            <a:r>
-              <a:rPr sz="1000" b="1" i="0">
-                <a:solidFill>
-                  <a:srgbClr val="0070C0"/>
-                </a:solidFill>
-                <a:latin typeface="Calibri"/>
-              </a:rPr>
-              <a:t>7.  </a:t>
-            </a:r>
-            <a:r>
-              <a:rPr sz="1000" b="1" i="0">
-                <a:solidFill>
-                  <a:srgbClr val="1F3F6E"/>
-                </a:solidFill>
-                <a:latin typeface="Calibri"/>
-              </a:rPr>
-              <a:t>Supabase RLS, Vercel functions docs</a:t>
-            </a:r>
-            <a:r>
-              <a:rPr sz="1000" b="0" i="0">
-                <a:solidFill>
-                  <a:srgbClr val="1F2937"/>
-                </a:solidFill>
-                <a:latin typeface="Calibri"/>
-              </a:rPr>
-              <a:t/>
-            </a:r>
-          </a:p>
-          <a:p>
-            <a:pPr>
-              <a:spcAft>
-                <a:spcPts val="300"/>
-              </a:spcAft>
-            </a:pPr>
-            <a:r>
-              <a:rPr sz="1000" b="1" i="0">
-                <a:solidFill>
-                  <a:srgbClr val="0070C0"/>
-                </a:solidFill>
-                <a:latin typeface="Calibri"/>
-              </a:rPr>
-              <a:t>8.  </a:t>
-            </a:r>
-            <a:r>
-              <a:rPr sz="1000" b="1" i="0">
-                <a:solidFill>
-                  <a:srgbClr val="1F3F6E"/>
-                </a:solidFill>
-                <a:latin typeface="Calibri"/>
-              </a:rPr>
-              <a:t>Google Gemini API docs</a:t>
-            </a:r>
-            <a:r>
-              <a:rPr sz="1000" b="0" i="0">
-                <a:solidFill>
-                  <a:srgbClr val="1F2937"/>
-                </a:solidFill>
-                <a:latin typeface="Calibri"/>
-              </a:rPr>
-              <a:t> · ai.google.dev</a:t>
-            </a:r>
-          </a:p>
-        </p:txBody>
-      </p:sp>
-      <p:sp>
-        <p:nvSpPr>
-          <p:cNvPr id="17436" name="Rounded Rectangle 17435"/>
+              <a:t>Certificate</a:t>
+            </a:r>
+          </a:p>
+        </p:txBody>
+      </p:sp>
+      <p:sp>
+        <p:nvSpPr>
+          <p:cNvPr id="17442" name="Rectangle 17441"/>
           <p:cNvSpPr/>
           <p:nvPr/>
         </p:nvSpPr>
         <p:spPr>
           <a:xfrm>
-            <a:off x="7589520" y="4892040"/>
-            <a:ext cx="4233672" cy="1344168"/>
-          </a:xfrm>
-          <a:prstGeom prst="roundRect">
-            <a:avLst>
-              <a:gd name="adj" fmla="val 4081"/>
-            </a:avLst>
+            <a:off x="8641080" y="3840480"/>
+            <a:ext cx="868680" cy="201168"/>
+          </a:xfrm>
+          <a:prstGeom prst="rect">
+            <a:avLst/>
+          </a:prstGeom>
+          <a:solidFill>
+            <a:srgbClr val="F1F4F8"/>
+          </a:solidFill>
+          <a:ln>
+            <a:noFill/>
+          </a:ln>
+          <a:effectLst/>
+        </p:spPr>
+        <p:style>
+          <a:lnRef idx="1">
+            <a:schemeClr val="accent1"/>
+          </a:lnRef>
+          <a:fillRef idx="3">
+            <a:schemeClr val="accent1"/>
+          </a:fillRef>
+          <a:effectRef idx="2">
+            <a:schemeClr val="accent1"/>
+          </a:effectRef>
+          <a:fontRef idx="minor">
+            <a:schemeClr val="lt1"/>
+          </a:fontRef>
+        </p:style>
+        <p:txBody>
+          <a:bodyPr rtlCol="0" anchor="ctr" wrap="square" lIns="45720" rIns="45720" tIns="27432" bIns="27432"/>
+          <a:lstStyle/>
+          <a:p>
+            <a:pPr algn="l"/>
+            <a:r>
+              <a:rPr sz="800" b="0" i="0">
+                <a:solidFill>
+                  <a:srgbClr val="5B6573"/>
+                </a:solidFill>
+                <a:latin typeface="Calibri"/>
+              </a:rPr>
+              <a:t>copyable paper</a:t>
+            </a:r>
+          </a:p>
+        </p:txBody>
+      </p:sp>
+      <p:sp>
+        <p:nvSpPr>
+          <p:cNvPr id="17443" name="Rectangle 17442"/>
+          <p:cNvSpPr/>
+          <p:nvPr/>
+        </p:nvSpPr>
+        <p:spPr>
+          <a:xfrm>
+            <a:off x="9509760" y="3840480"/>
+            <a:ext cx="1097280" cy="201168"/>
+          </a:xfrm>
+          <a:prstGeom prst="rect">
+            <a:avLst/>
+          </a:prstGeom>
+          <a:solidFill>
+            <a:srgbClr val="F1F4F8"/>
+          </a:solidFill>
+          <a:ln>
+            <a:noFill/>
+          </a:ln>
+          <a:effectLst/>
+        </p:spPr>
+        <p:style>
+          <a:lnRef idx="1">
+            <a:schemeClr val="accent1"/>
+          </a:lnRef>
+          <a:fillRef idx="3">
+            <a:schemeClr val="accent1"/>
+          </a:fillRef>
+          <a:effectRef idx="2">
+            <a:schemeClr val="accent1"/>
+          </a:effectRef>
+          <a:fontRef idx="minor">
+            <a:schemeClr val="lt1"/>
+          </a:fontRef>
+        </p:style>
+        <p:txBody>
+          <a:bodyPr rtlCol="0" anchor="ctr" wrap="square" lIns="45720" rIns="45720" tIns="27432" bIns="27432"/>
+          <a:lstStyle/>
+          <a:p>
+            <a:pPr algn="l"/>
+            <a:r>
+              <a:rPr sz="800" b="0" i="0">
+                <a:solidFill>
+                  <a:srgbClr val="5B6573"/>
+                </a:solidFill>
+                <a:latin typeface="Calibri"/>
+              </a:rPr>
+              <a:t>editable PDF</a:t>
+            </a:r>
+          </a:p>
+        </p:txBody>
+      </p:sp>
+      <p:sp>
+        <p:nvSpPr>
+          <p:cNvPr id="17444" name="Rectangle 17443"/>
+          <p:cNvSpPr/>
+          <p:nvPr/>
+        </p:nvSpPr>
+        <p:spPr>
+          <a:xfrm>
+            <a:off x="10607040" y="3840480"/>
+            <a:ext cx="1216152" cy="201168"/>
+          </a:xfrm>
+          <a:prstGeom prst="rect">
+            <a:avLst/>
           </a:prstGeom>
           <a:solidFill>
             <a:srgbClr val="E6F4EC"/>
@@ -20060,6 +20470,909 @@
           </a:fontRef>
         </p:style>
         <p:txBody>
+          <a:bodyPr rtlCol="0" anchor="ctr" wrap="square" lIns="45720" rIns="45720" tIns="27432" bIns="27432"/>
+          <a:lstStyle/>
+          <a:p>
+            <a:pPr algn="l"/>
+            <a:r>
+              <a:rPr sz="800" b="1" i="0">
+                <a:solidFill>
+                  <a:srgbClr val="1E7B4A"/>
+                </a:solidFill>
+                <a:latin typeface="Calibri"/>
+              </a:rPr>
+              <a:t>signed QR</a:t>
+            </a:r>
+          </a:p>
+        </p:txBody>
+      </p:sp>
+      <p:sp>
+        <p:nvSpPr>
+          <p:cNvPr id="17445" name="Rectangle 17444"/>
+          <p:cNvSpPr/>
+          <p:nvPr/>
+        </p:nvSpPr>
+        <p:spPr>
+          <a:xfrm>
+            <a:off x="7589520" y="4041648"/>
+            <a:ext cx="1051560" cy="201168"/>
+          </a:xfrm>
+          <a:prstGeom prst="rect">
+            <a:avLst/>
+          </a:prstGeom>
+          <a:solidFill>
+            <a:srgbClr val="FFFFFF"/>
+          </a:solidFill>
+          <a:ln>
+            <a:noFill/>
+          </a:ln>
+          <a:effectLst/>
+        </p:spPr>
+        <p:style>
+          <a:lnRef idx="1">
+            <a:schemeClr val="accent1"/>
+          </a:lnRef>
+          <a:fillRef idx="3">
+            <a:schemeClr val="accent1"/>
+          </a:fillRef>
+          <a:effectRef idx="2">
+            <a:schemeClr val="accent1"/>
+          </a:effectRef>
+          <a:fontRef idx="minor">
+            <a:schemeClr val="lt1"/>
+          </a:fontRef>
+        </p:style>
+        <p:txBody>
+          <a:bodyPr rtlCol="0" anchor="ctr" wrap="square" lIns="45720" rIns="45720" tIns="27432" bIns="27432"/>
+          <a:lstStyle/>
+          <a:p>
+            <a:pPr algn="l"/>
+            <a:r>
+              <a:rPr sz="800" b="1" i="0">
+                <a:solidFill>
+                  <a:srgbClr val="1F2937"/>
+                </a:solidFill>
+                <a:latin typeface="Calibri"/>
+              </a:rPr>
+              <a:t>Buyer can check</a:t>
+            </a:r>
+          </a:p>
+        </p:txBody>
+      </p:sp>
+      <p:sp>
+        <p:nvSpPr>
+          <p:cNvPr id="17446" name="Rectangle 17445"/>
+          <p:cNvSpPr/>
+          <p:nvPr/>
+        </p:nvSpPr>
+        <p:spPr>
+          <a:xfrm>
+            <a:off x="8641080" y="4041648"/>
+            <a:ext cx="868680" cy="201168"/>
+          </a:xfrm>
+          <a:prstGeom prst="rect">
+            <a:avLst/>
+          </a:prstGeom>
+          <a:solidFill>
+            <a:srgbClr val="FFFFFF"/>
+          </a:solidFill>
+          <a:ln>
+            <a:noFill/>
+          </a:ln>
+          <a:effectLst/>
+        </p:spPr>
+        <p:style>
+          <a:lnRef idx="1">
+            <a:schemeClr val="accent1"/>
+          </a:lnRef>
+          <a:fillRef idx="3">
+            <a:schemeClr val="accent1"/>
+          </a:fillRef>
+          <a:effectRef idx="2">
+            <a:schemeClr val="accent1"/>
+          </a:effectRef>
+          <a:fontRef idx="minor">
+            <a:schemeClr val="lt1"/>
+          </a:fontRef>
+        </p:style>
+        <p:txBody>
+          <a:bodyPr rtlCol="0" anchor="ctr" wrap="square" lIns="45720" rIns="45720" tIns="27432" bIns="27432"/>
+          <a:lstStyle/>
+          <a:p>
+            <a:pPr algn="l"/>
+            <a:r>
+              <a:rPr sz="800" b="0" i="0">
+                <a:solidFill>
+                  <a:srgbClr val="5B6573"/>
+                </a:solidFill>
+                <a:latin typeface="Calibri"/>
+              </a:rPr>
+              <a:t>no</a:t>
+            </a:r>
+          </a:p>
+        </p:txBody>
+      </p:sp>
+      <p:sp>
+        <p:nvSpPr>
+          <p:cNvPr id="17447" name="Rectangle 17446"/>
+          <p:cNvSpPr/>
+          <p:nvPr/>
+        </p:nvSpPr>
+        <p:spPr>
+          <a:xfrm>
+            <a:off x="9509760" y="4041648"/>
+            <a:ext cx="1097280" cy="201168"/>
+          </a:xfrm>
+          <a:prstGeom prst="rect">
+            <a:avLst/>
+          </a:prstGeom>
+          <a:solidFill>
+            <a:srgbClr val="FFFFFF"/>
+          </a:solidFill>
+          <a:ln>
+            <a:noFill/>
+          </a:ln>
+          <a:effectLst/>
+        </p:spPr>
+        <p:style>
+          <a:lnRef idx="1">
+            <a:schemeClr val="accent1"/>
+          </a:lnRef>
+          <a:fillRef idx="3">
+            <a:schemeClr val="accent1"/>
+          </a:fillRef>
+          <a:effectRef idx="2">
+            <a:schemeClr val="accent1"/>
+          </a:effectRef>
+          <a:fontRef idx="minor">
+            <a:schemeClr val="lt1"/>
+          </a:fontRef>
+        </p:style>
+        <p:txBody>
+          <a:bodyPr rtlCol="0" anchor="ctr" wrap="square" lIns="45720" rIns="45720" tIns="27432" bIns="27432"/>
+          <a:lstStyle/>
+          <a:p>
+            <a:pPr algn="l"/>
+            <a:r>
+              <a:rPr sz="800" b="0" i="0">
+                <a:solidFill>
+                  <a:srgbClr val="5B6573"/>
+                </a:solidFill>
+                <a:latin typeface="Calibri"/>
+              </a:rPr>
+              <a:t>rarely</a:t>
+            </a:r>
+          </a:p>
+        </p:txBody>
+      </p:sp>
+      <p:sp>
+        <p:nvSpPr>
+          <p:cNvPr id="17448" name="Rectangle 17447"/>
+          <p:cNvSpPr/>
+          <p:nvPr/>
+        </p:nvSpPr>
+        <p:spPr>
+          <a:xfrm>
+            <a:off x="10607040" y="4041648"/>
+            <a:ext cx="1216152" cy="201168"/>
+          </a:xfrm>
+          <a:prstGeom prst="rect">
+            <a:avLst/>
+          </a:prstGeom>
+          <a:solidFill>
+            <a:srgbClr val="E6F4EC"/>
+          </a:solidFill>
+          <a:ln>
+            <a:noFill/>
+          </a:ln>
+          <a:effectLst/>
+        </p:spPr>
+        <p:style>
+          <a:lnRef idx="1">
+            <a:schemeClr val="accent1"/>
+          </a:lnRef>
+          <a:fillRef idx="3">
+            <a:schemeClr val="accent1"/>
+          </a:fillRef>
+          <a:effectRef idx="2">
+            <a:schemeClr val="accent1"/>
+          </a:effectRef>
+          <a:fontRef idx="minor">
+            <a:schemeClr val="lt1"/>
+          </a:fontRef>
+        </p:style>
+        <p:txBody>
+          <a:bodyPr rtlCol="0" anchor="ctr" wrap="square" lIns="45720" rIns="45720" tIns="27432" bIns="27432"/>
+          <a:lstStyle/>
+          <a:p>
+            <a:pPr algn="l"/>
+            <a:r>
+              <a:rPr sz="800" b="1" i="0">
+                <a:solidFill>
+                  <a:srgbClr val="1E7B4A"/>
+                </a:solidFill>
+                <a:latin typeface="Calibri"/>
+              </a:rPr>
+              <a:t>any phone, offline</a:t>
+            </a:r>
+          </a:p>
+        </p:txBody>
+      </p:sp>
+      <p:sp>
+        <p:nvSpPr>
+          <p:cNvPr id="17449" name="Rectangle 17448"/>
+          <p:cNvSpPr/>
+          <p:nvPr/>
+        </p:nvSpPr>
+        <p:spPr>
+          <a:xfrm>
+            <a:off x="7589520" y="4242816"/>
+            <a:ext cx="1051560" cy="201168"/>
+          </a:xfrm>
+          <a:prstGeom prst="rect">
+            <a:avLst/>
+          </a:prstGeom>
+          <a:solidFill>
+            <a:srgbClr val="F1F4F8"/>
+          </a:solidFill>
+          <a:ln>
+            <a:noFill/>
+          </a:ln>
+          <a:effectLst/>
+        </p:spPr>
+        <p:style>
+          <a:lnRef idx="1">
+            <a:schemeClr val="accent1"/>
+          </a:lnRef>
+          <a:fillRef idx="3">
+            <a:schemeClr val="accent1"/>
+          </a:fillRef>
+          <a:effectRef idx="2">
+            <a:schemeClr val="accent1"/>
+          </a:effectRef>
+          <a:fontRef idx="minor">
+            <a:schemeClr val="lt1"/>
+          </a:fontRef>
+        </p:style>
+        <p:txBody>
+          <a:bodyPr rtlCol="0" anchor="ctr" wrap="square" lIns="45720" rIns="45720" tIns="27432" bIns="27432"/>
+          <a:lstStyle/>
+          <a:p>
+            <a:pPr algn="l"/>
+            <a:r>
+              <a:rPr sz="800" b="1" i="0">
+                <a:solidFill>
+                  <a:srgbClr val="1F2937"/>
+                </a:solidFill>
+                <a:latin typeface="Calibri"/>
+              </a:rPr>
+              <a:t>Field record</a:t>
+            </a:r>
+          </a:p>
+        </p:txBody>
+      </p:sp>
+      <p:sp>
+        <p:nvSpPr>
+          <p:cNvPr id="17450" name="Rectangle 17449"/>
+          <p:cNvSpPr/>
+          <p:nvPr/>
+        </p:nvSpPr>
+        <p:spPr>
+          <a:xfrm>
+            <a:off x="8641080" y="4242816"/>
+            <a:ext cx="868680" cy="201168"/>
+          </a:xfrm>
+          <a:prstGeom prst="rect">
+            <a:avLst/>
+          </a:prstGeom>
+          <a:solidFill>
+            <a:srgbClr val="F1F4F8"/>
+          </a:solidFill>
+          <a:ln>
+            <a:noFill/>
+          </a:ln>
+          <a:effectLst/>
+        </p:spPr>
+        <p:style>
+          <a:lnRef idx="1">
+            <a:schemeClr val="accent1"/>
+          </a:lnRef>
+          <a:fillRef idx="3">
+            <a:schemeClr val="accent1"/>
+          </a:fillRef>
+          <a:effectRef idx="2">
+            <a:schemeClr val="accent1"/>
+          </a:effectRef>
+          <a:fontRef idx="minor">
+            <a:schemeClr val="lt1"/>
+          </a:fontRef>
+        </p:style>
+        <p:txBody>
+          <a:bodyPr rtlCol="0" anchor="ctr" wrap="square" lIns="45720" rIns="45720" tIns="27432" bIns="27432"/>
+          <a:lstStyle/>
+          <a:p>
+            <a:pPr algn="l"/>
+            <a:r>
+              <a:rPr sz="800" b="0" i="0">
+                <a:solidFill>
+                  <a:srgbClr val="5B6573"/>
+                </a:solidFill>
+                <a:latin typeface="Calibri"/>
+              </a:rPr>
+              <a:t>register</a:t>
+            </a:r>
+          </a:p>
+        </p:txBody>
+      </p:sp>
+      <p:sp>
+        <p:nvSpPr>
+          <p:cNvPr id="17451" name="Rectangle 17450"/>
+          <p:cNvSpPr/>
+          <p:nvPr/>
+        </p:nvSpPr>
+        <p:spPr>
+          <a:xfrm>
+            <a:off x="9509760" y="4242816"/>
+            <a:ext cx="1097280" cy="201168"/>
+          </a:xfrm>
+          <a:prstGeom prst="rect">
+            <a:avLst/>
+          </a:prstGeom>
+          <a:solidFill>
+            <a:srgbClr val="F1F4F8"/>
+          </a:solidFill>
+          <a:ln>
+            <a:noFill/>
+          </a:ln>
+          <a:effectLst/>
+        </p:spPr>
+        <p:style>
+          <a:lnRef idx="1">
+            <a:schemeClr val="accent1"/>
+          </a:lnRef>
+          <a:fillRef idx="3">
+            <a:schemeClr val="accent1"/>
+          </a:fillRef>
+          <a:effectRef idx="2">
+            <a:schemeClr val="accent1"/>
+          </a:effectRef>
+          <a:fontRef idx="minor">
+            <a:schemeClr val="lt1"/>
+          </a:fontRef>
+        </p:style>
+        <p:txBody>
+          <a:bodyPr rtlCol="0" anchor="ctr" wrap="square" lIns="45720" rIns="45720" tIns="27432" bIns="27432"/>
+          <a:lstStyle/>
+          <a:p>
+            <a:pPr algn="l"/>
+            <a:r>
+              <a:rPr sz="800" b="0" i="0">
+                <a:solidFill>
+                  <a:srgbClr val="5B6573"/>
+                </a:solidFill>
+                <a:latin typeface="Calibri"/>
+              </a:rPr>
+              <a:t>typed later</a:t>
+            </a:r>
+          </a:p>
+        </p:txBody>
+      </p:sp>
+      <p:sp>
+        <p:nvSpPr>
+          <p:cNvPr id="17452" name="Rectangle 17451"/>
+          <p:cNvSpPr/>
+          <p:nvPr/>
+        </p:nvSpPr>
+        <p:spPr>
+          <a:xfrm>
+            <a:off x="10607040" y="4242816"/>
+            <a:ext cx="1216152" cy="201168"/>
+          </a:xfrm>
+          <a:prstGeom prst="rect">
+            <a:avLst/>
+          </a:prstGeom>
+          <a:solidFill>
+            <a:srgbClr val="E6F4EC"/>
+          </a:solidFill>
+          <a:ln>
+            <a:noFill/>
+          </a:ln>
+          <a:effectLst/>
+        </p:spPr>
+        <p:style>
+          <a:lnRef idx="1">
+            <a:schemeClr val="accent1"/>
+          </a:lnRef>
+          <a:fillRef idx="3">
+            <a:schemeClr val="accent1"/>
+          </a:fillRef>
+          <a:effectRef idx="2">
+            <a:schemeClr val="accent1"/>
+          </a:effectRef>
+          <a:fontRef idx="minor">
+            <a:schemeClr val="lt1"/>
+          </a:fontRef>
+        </p:style>
+        <p:txBody>
+          <a:bodyPr rtlCol="0" anchor="ctr" wrap="square" lIns="45720" rIns="45720" tIns="27432" bIns="27432"/>
+          <a:lstStyle/>
+          <a:p>
+            <a:pPr algn="l"/>
+            <a:r>
+              <a:rPr sz="800" b="1" i="0">
+                <a:solidFill>
+                  <a:srgbClr val="1E7B4A"/>
+                </a:solidFill>
+                <a:latin typeface="Calibri"/>
+              </a:rPr>
+              <a:t>phone, offline</a:t>
+            </a:r>
+          </a:p>
+        </p:txBody>
+      </p:sp>
+      <p:sp>
+        <p:nvSpPr>
+          <p:cNvPr id="17453" name="Rectangle 17452"/>
+          <p:cNvSpPr/>
+          <p:nvPr/>
+        </p:nvSpPr>
+        <p:spPr>
+          <a:xfrm>
+            <a:off x="7589520" y="4443984"/>
+            <a:ext cx="1051560" cy="201168"/>
+          </a:xfrm>
+          <a:prstGeom prst="rect">
+            <a:avLst/>
+          </a:prstGeom>
+          <a:solidFill>
+            <a:srgbClr val="FFFFFF"/>
+          </a:solidFill>
+          <a:ln>
+            <a:noFill/>
+          </a:ln>
+          <a:effectLst/>
+        </p:spPr>
+        <p:style>
+          <a:lnRef idx="1">
+            <a:schemeClr val="accent1"/>
+          </a:lnRef>
+          <a:fillRef idx="3">
+            <a:schemeClr val="accent1"/>
+          </a:fillRef>
+          <a:effectRef idx="2">
+            <a:schemeClr val="accent1"/>
+          </a:effectRef>
+          <a:fontRef idx="minor">
+            <a:schemeClr val="lt1"/>
+          </a:fontRef>
+        </p:style>
+        <p:txBody>
+          <a:bodyPr rtlCol="0" anchor="ctr" wrap="square" lIns="45720" rIns="45720" tIns="27432" bIns="27432"/>
+          <a:lstStyle/>
+          <a:p>
+            <a:pPr algn="l"/>
+            <a:r>
+              <a:rPr sz="800" b="1" i="0">
+                <a:solidFill>
+                  <a:srgbClr val="1F2937"/>
+                </a:solidFill>
+                <a:latin typeface="Calibri"/>
+              </a:rPr>
+              <a:t>Pass / fail</a:t>
+            </a:r>
+          </a:p>
+        </p:txBody>
+      </p:sp>
+      <p:sp>
+        <p:nvSpPr>
+          <p:cNvPr id="17454" name="Rectangle 17453"/>
+          <p:cNvSpPr/>
+          <p:nvPr/>
+        </p:nvSpPr>
+        <p:spPr>
+          <a:xfrm>
+            <a:off x="8641080" y="4443984"/>
+            <a:ext cx="868680" cy="201168"/>
+          </a:xfrm>
+          <a:prstGeom prst="rect">
+            <a:avLst/>
+          </a:prstGeom>
+          <a:solidFill>
+            <a:srgbClr val="FFFFFF"/>
+          </a:solidFill>
+          <a:ln>
+            <a:noFill/>
+          </a:ln>
+          <a:effectLst/>
+        </p:spPr>
+        <p:style>
+          <a:lnRef idx="1">
+            <a:schemeClr val="accent1"/>
+          </a:lnRef>
+          <a:fillRef idx="3">
+            <a:schemeClr val="accent1"/>
+          </a:fillRef>
+          <a:effectRef idx="2">
+            <a:schemeClr val="accent1"/>
+          </a:effectRef>
+          <a:fontRef idx="minor">
+            <a:schemeClr val="lt1"/>
+          </a:fontRef>
+        </p:style>
+        <p:txBody>
+          <a:bodyPr rtlCol="0" anchor="ctr" wrap="square" lIns="45720" rIns="45720" tIns="27432" bIns="27432"/>
+          <a:lstStyle/>
+          <a:p>
+            <a:pPr algn="l"/>
+            <a:r>
+              <a:rPr sz="800" b="0" i="0">
+                <a:solidFill>
+                  <a:srgbClr val="5B6573"/>
+                </a:solidFill>
+                <a:latin typeface="Calibri"/>
+              </a:rPr>
+              <a:t>judgement</a:t>
+            </a:r>
+          </a:p>
+        </p:txBody>
+      </p:sp>
+      <p:sp>
+        <p:nvSpPr>
+          <p:cNvPr id="17455" name="Rectangle 17454"/>
+          <p:cNvSpPr/>
+          <p:nvPr/>
+        </p:nvSpPr>
+        <p:spPr>
+          <a:xfrm>
+            <a:off x="9509760" y="4443984"/>
+            <a:ext cx="1097280" cy="201168"/>
+          </a:xfrm>
+          <a:prstGeom prst="rect">
+            <a:avLst/>
+          </a:prstGeom>
+          <a:solidFill>
+            <a:srgbClr val="FFFFFF"/>
+          </a:solidFill>
+          <a:ln>
+            <a:noFill/>
+          </a:ln>
+          <a:effectLst/>
+        </p:spPr>
+        <p:style>
+          <a:lnRef idx="1">
+            <a:schemeClr val="accent1"/>
+          </a:lnRef>
+          <a:fillRef idx="3">
+            <a:schemeClr val="accent1"/>
+          </a:fillRef>
+          <a:effectRef idx="2">
+            <a:schemeClr val="accent1"/>
+          </a:effectRef>
+          <a:fontRef idx="minor">
+            <a:schemeClr val="lt1"/>
+          </a:fontRef>
+        </p:style>
+        <p:txBody>
+          <a:bodyPr rtlCol="0" anchor="ctr" wrap="square" lIns="45720" rIns="45720" tIns="27432" bIns="27432"/>
+          <a:lstStyle/>
+          <a:p>
+            <a:pPr algn="l"/>
+            <a:r>
+              <a:rPr sz="800" b="0" i="0">
+                <a:solidFill>
+                  <a:srgbClr val="5B6573"/>
+                </a:solidFill>
+                <a:latin typeface="Calibri"/>
+              </a:rPr>
+              <a:t>typed</a:t>
+            </a:r>
+          </a:p>
+        </p:txBody>
+      </p:sp>
+      <p:sp>
+        <p:nvSpPr>
+          <p:cNvPr id="17456" name="Rectangle 17455"/>
+          <p:cNvSpPr/>
+          <p:nvPr/>
+        </p:nvSpPr>
+        <p:spPr>
+          <a:xfrm>
+            <a:off x="10607040" y="4443984"/>
+            <a:ext cx="1216152" cy="201168"/>
+          </a:xfrm>
+          <a:prstGeom prst="rect">
+            <a:avLst/>
+          </a:prstGeom>
+          <a:solidFill>
+            <a:srgbClr val="E6F4EC"/>
+          </a:solidFill>
+          <a:ln>
+            <a:noFill/>
+          </a:ln>
+          <a:effectLst/>
+        </p:spPr>
+        <p:style>
+          <a:lnRef idx="1">
+            <a:schemeClr val="accent1"/>
+          </a:lnRef>
+          <a:fillRef idx="3">
+            <a:schemeClr val="accent1"/>
+          </a:fillRef>
+          <a:effectRef idx="2">
+            <a:schemeClr val="accent1"/>
+          </a:effectRef>
+          <a:fontRef idx="minor">
+            <a:schemeClr val="lt1"/>
+          </a:fontRef>
+        </p:style>
+        <p:txBody>
+          <a:bodyPr rtlCol="0" anchor="ctr" wrap="square" lIns="45720" rIns="45720" tIns="27432" bIns="27432"/>
+          <a:lstStyle/>
+          <a:p>
+            <a:pPr algn="l"/>
+            <a:r>
+              <a:rPr sz="800" b="1" i="0">
+                <a:solidFill>
+                  <a:srgbClr val="1E7B4A"/>
+                </a:solidFill>
+                <a:latin typeface="Calibri"/>
+              </a:rPr>
+              <a:t>computed vs MPE</a:t>
+            </a:r>
+          </a:p>
+        </p:txBody>
+      </p:sp>
+      <p:sp>
+        <p:nvSpPr>
+          <p:cNvPr id="17457" name="Rectangle 17456"/>
+          <p:cNvSpPr/>
+          <p:nvPr/>
+        </p:nvSpPr>
+        <p:spPr>
+          <a:xfrm>
+            <a:off x="7589520" y="4645152"/>
+            <a:ext cx="1051560" cy="201168"/>
+          </a:xfrm>
+          <a:prstGeom prst="rect">
+            <a:avLst/>
+          </a:prstGeom>
+          <a:solidFill>
+            <a:srgbClr val="F1F4F8"/>
+          </a:solidFill>
+          <a:ln>
+            <a:noFill/>
+          </a:ln>
+          <a:effectLst/>
+        </p:spPr>
+        <p:style>
+          <a:lnRef idx="1">
+            <a:schemeClr val="accent1"/>
+          </a:lnRef>
+          <a:fillRef idx="3">
+            <a:schemeClr val="accent1"/>
+          </a:fillRef>
+          <a:effectRef idx="2">
+            <a:schemeClr val="accent1"/>
+          </a:effectRef>
+          <a:fontRef idx="minor">
+            <a:schemeClr val="lt1"/>
+          </a:fontRef>
+        </p:style>
+        <p:txBody>
+          <a:bodyPr rtlCol="0" anchor="ctr" wrap="square" lIns="45720" rIns="45720" tIns="27432" bIns="27432"/>
+          <a:lstStyle/>
+          <a:p>
+            <a:pPr algn="l"/>
+            <a:r>
+              <a:rPr sz="800" b="1" i="0">
+                <a:solidFill>
+                  <a:srgbClr val="1F2937"/>
+                </a:solidFill>
+                <a:latin typeface="Calibri"/>
+              </a:rPr>
+              <a:t>Across States</a:t>
+            </a:r>
+          </a:p>
+        </p:txBody>
+      </p:sp>
+      <p:sp>
+        <p:nvSpPr>
+          <p:cNvPr id="17458" name="Rectangle 17457"/>
+          <p:cNvSpPr/>
+          <p:nvPr/>
+        </p:nvSpPr>
+        <p:spPr>
+          <a:xfrm>
+            <a:off x="8641080" y="4645152"/>
+            <a:ext cx="868680" cy="201168"/>
+          </a:xfrm>
+          <a:prstGeom prst="rect">
+            <a:avLst/>
+          </a:prstGeom>
+          <a:solidFill>
+            <a:srgbClr val="F1F4F8"/>
+          </a:solidFill>
+          <a:ln>
+            <a:noFill/>
+          </a:ln>
+          <a:effectLst/>
+        </p:spPr>
+        <p:style>
+          <a:lnRef idx="1">
+            <a:schemeClr val="accent1"/>
+          </a:lnRef>
+          <a:fillRef idx="3">
+            <a:schemeClr val="accent1"/>
+          </a:fillRef>
+          <a:effectRef idx="2">
+            <a:schemeClr val="accent1"/>
+          </a:effectRef>
+          <a:fontRef idx="minor">
+            <a:schemeClr val="lt1"/>
+          </a:fontRef>
+        </p:style>
+        <p:txBody>
+          <a:bodyPr rtlCol="0" anchor="ctr" wrap="square" lIns="45720" rIns="45720" tIns="27432" bIns="27432"/>
+          <a:lstStyle/>
+          <a:p>
+            <a:pPr algn="l"/>
+            <a:r>
+              <a:rPr sz="800" b="0" i="0">
+                <a:solidFill>
+                  <a:srgbClr val="5B6573"/>
+                </a:solidFill>
+                <a:latin typeface="Calibri"/>
+              </a:rPr>
+              <a:t>separate</a:t>
+            </a:r>
+          </a:p>
+        </p:txBody>
+      </p:sp>
+      <p:sp>
+        <p:nvSpPr>
+          <p:cNvPr id="17459" name="Rectangle 17458"/>
+          <p:cNvSpPr/>
+          <p:nvPr/>
+        </p:nvSpPr>
+        <p:spPr>
+          <a:xfrm>
+            <a:off x="9509760" y="4645152"/>
+            <a:ext cx="1097280" cy="201168"/>
+          </a:xfrm>
+          <a:prstGeom prst="rect">
+            <a:avLst/>
+          </a:prstGeom>
+          <a:solidFill>
+            <a:srgbClr val="F1F4F8"/>
+          </a:solidFill>
+          <a:ln>
+            <a:noFill/>
+          </a:ln>
+          <a:effectLst/>
+        </p:spPr>
+        <p:style>
+          <a:lnRef idx="1">
+            <a:schemeClr val="accent1"/>
+          </a:lnRef>
+          <a:fillRef idx="3">
+            <a:schemeClr val="accent1"/>
+          </a:fillRef>
+          <a:effectRef idx="2">
+            <a:schemeClr val="accent1"/>
+          </a:effectRef>
+          <a:fontRef idx="minor">
+            <a:schemeClr val="lt1"/>
+          </a:fontRef>
+        </p:style>
+        <p:txBody>
+          <a:bodyPr rtlCol="0" anchor="ctr" wrap="square" lIns="45720" rIns="45720" tIns="27432" bIns="27432"/>
+          <a:lstStyle/>
+          <a:p>
+            <a:pPr algn="l"/>
+            <a:r>
+              <a:rPr sz="800" b="0" i="0">
+                <a:solidFill>
+                  <a:srgbClr val="5B6573"/>
+                </a:solidFill>
+                <a:latin typeface="Calibri"/>
+              </a:rPr>
+              <a:t>one per State</a:t>
+            </a:r>
+          </a:p>
+        </p:txBody>
+      </p:sp>
+      <p:sp>
+        <p:nvSpPr>
+          <p:cNvPr id="17460" name="Rectangle 17459"/>
+          <p:cNvSpPr/>
+          <p:nvPr/>
+        </p:nvSpPr>
+        <p:spPr>
+          <a:xfrm>
+            <a:off x="10607040" y="4645152"/>
+            <a:ext cx="1216152" cy="201168"/>
+          </a:xfrm>
+          <a:prstGeom prst="rect">
+            <a:avLst/>
+          </a:prstGeom>
+          <a:solidFill>
+            <a:srgbClr val="E6F4EC"/>
+          </a:solidFill>
+          <a:ln>
+            <a:noFill/>
+          </a:ln>
+          <a:effectLst/>
+        </p:spPr>
+        <p:style>
+          <a:lnRef idx="1">
+            <a:schemeClr val="accent1"/>
+          </a:lnRef>
+          <a:fillRef idx="3">
+            <a:schemeClr val="accent1"/>
+          </a:fillRef>
+          <a:effectRef idx="2">
+            <a:schemeClr val="accent1"/>
+          </a:effectRef>
+          <a:fontRef idx="minor">
+            <a:schemeClr val="lt1"/>
+          </a:fontRef>
+        </p:style>
+        <p:txBody>
+          <a:bodyPr rtlCol="0" anchor="ctr" wrap="square" lIns="45720" rIns="45720" tIns="27432" bIns="27432"/>
+          <a:lstStyle/>
+          <a:p>
+            <a:pPr algn="l"/>
+            <a:r>
+              <a:rPr sz="800" b="1" i="0">
+                <a:solidFill>
+                  <a:srgbClr val="1E7B4A"/>
+                </a:solidFill>
+                <a:latin typeface="Calibri"/>
+              </a:rPr>
+              <a:t>one platform</a:t>
+            </a:r>
+          </a:p>
+        </p:txBody>
+      </p:sp>
+      <p:sp>
+        <p:nvSpPr>
+          <p:cNvPr id="17461" name="Rounded Rectangle 17460"/>
+          <p:cNvSpPr/>
+          <p:nvPr/>
+        </p:nvSpPr>
+        <p:spPr>
+          <a:xfrm>
+            <a:off x="7589520" y="4892040"/>
+            <a:ext cx="4233672" cy="1344168"/>
+          </a:xfrm>
+          <a:prstGeom prst="roundRect">
+            <a:avLst>
+              <a:gd name="adj" fmla="val 4081"/>
+            </a:avLst>
+          </a:prstGeom>
+          <a:solidFill>
+            <a:srgbClr val="E6F4EC"/>
+          </a:solidFill>
+          <a:ln>
+            <a:noFill/>
+          </a:ln>
+          <a:effectLst/>
+        </p:spPr>
+        <p:style>
+          <a:lnRef idx="1">
+            <a:schemeClr val="accent1"/>
+          </a:lnRef>
+          <a:fillRef idx="3">
+            <a:schemeClr val="accent1"/>
+          </a:fillRef>
+          <a:effectRef idx="2">
+            <a:schemeClr val="accent1"/>
+          </a:effectRef>
+          <a:fontRef idx="minor">
+            <a:schemeClr val="lt1"/>
+          </a:fontRef>
+        </p:style>
+        <p:txBody>
           <a:bodyPr rtlCol="0" anchor="ctr" wrap="square" lIns="54864" rIns="54864" tIns="27432" bIns="27432"/>
           <a:lstStyle/>
           <a:p>
@@ -20069,7 +21382,7 @@
       </p:sp>
       <p:pic>
         <p:nvPicPr>
-          <p:cNvPr id="17437" name="Picture 17436" descr="image.png"/>
+          <p:cNvPr id="17462" name="Picture 17461" descr="image.png"/>
           <p:cNvPicPr>
             <a:picLocks noChangeAspect="1"/>
           </p:cNvPicPr>
@@ -20093,7 +21406,7 @@
       </p:pic>
       <p:sp>
         <p:nvSpPr>
-          <p:cNvPr id="17438" name="TextBox 17437"/>
+          <p:cNvPr id="17463" name="TextBox 17462"/>
           <p:cNvSpPr txBox="1"/>
           <p:nvPr/>
         </p:nvSpPr>

</xml_diff>